<commit_message>
fix: refine cache admission and document concrete scheduling decisions
Separate idle-time and command savings, account for replacement pressure, and index promotion state. Refresh frozen validation and explain each scheduling decision with formulas and replayed examples.

Signed-off-by: KaisennHu <74917084+KaisennHu@users.noreply.github.com>
</commit_message>
<xml_diff>
--- a/submissions/kaisennhu/06_答辩演示/答辩幻灯片.pptx
+++ b/submissions/kaisennhu/06_答辩演示/答辩幻灯片.pptx
@@ -719,7 +719,7 @@
       </p:grpSpPr>
       <p:pic>
         <p:nvPicPr>
-          <p:cNvPr id="100" name="Presenton Native Image 1" descr=""/>
+          <p:cNvPr id="104" name="Presenton Native Image 1" descr=""/>
           <p:cNvPicPr/>
           <p:nvPr/>
         </p:nvPicPr>
@@ -741,7 +741,7 @@
       </p:pic>
       <p:sp>
         <p:nvSpPr>
-          <p:cNvPr id="2" name="Shape 2"/>
+          <p:cNvPr id="351" name="Shape 351"/>
           <p:cNvSpPr/>
           <p:nvPr/>
         </p:nvSpPr>
@@ -783,7 +783,7 @@
       </p:sp>
       <p:sp>
         <p:nvSpPr>
-          <p:cNvPr id="3" name="Shape 3"/>
+          <p:cNvPr id="352" name="Shape 352"/>
           <p:cNvSpPr/>
           <p:nvPr/>
         </p:nvSpPr>
@@ -825,7 +825,7 @@
       </p:sp>
       <p:sp>
         <p:nvSpPr>
-          <p:cNvPr id="4" name="Shape 4"/>
+          <p:cNvPr id="353" name="Shape 353"/>
           <p:cNvSpPr/>
           <p:nvPr/>
         </p:nvSpPr>
@@ -867,7 +867,7 @@
       </p:sp>
       <p:pic>
         <p:nvPicPr>
-          <p:cNvPr id="101" name="Presenton Native Image 2" descr=""/>
+          <p:cNvPr id="105" name="Presenton Native Image 2" descr=""/>
           <p:cNvPicPr/>
           <p:nvPr/>
         </p:nvPicPr>
@@ -889,7 +889,7 @@
       </p:pic>
       <p:sp>
         <p:nvSpPr>
-          <p:cNvPr id="5" name="Shape 5"/>
+          <p:cNvPr id="354" name="Shape 354"/>
           <p:cNvSpPr/>
           <p:nvPr/>
         </p:nvSpPr>
@@ -931,7 +931,7 @@
       </p:sp>
       <p:sp>
         <p:nvSpPr>
-          <p:cNvPr id="6" name="Shape 6"/>
+          <p:cNvPr id="355" name="Shape 355"/>
           <p:cNvSpPr/>
           <p:nvPr/>
         </p:nvSpPr>
@@ -973,7 +973,7 @@
       </p:sp>
       <p:sp>
         <p:nvSpPr>
-          <p:cNvPr id="7" name="Shape 7"/>
+          <p:cNvPr id="356" name="Shape 356"/>
           <p:cNvSpPr/>
           <p:nvPr/>
         </p:nvSpPr>
@@ -1057,7 +1057,7 @@
       </p:sp>
       <p:pic>
         <p:nvPicPr>
-          <p:cNvPr id="102" name="Presenton Native Image 3" descr=""/>
+          <p:cNvPr id="106" name="Presenton Native Image 3" descr=""/>
           <p:cNvPicPr/>
           <p:nvPr/>
         </p:nvPicPr>
@@ -1079,7 +1079,7 @@
       </p:pic>
       <p:sp>
         <p:nvSpPr>
-          <p:cNvPr id="8" name="Shape 8"/>
+          <p:cNvPr id="357" name="Shape 357"/>
           <p:cNvSpPr/>
           <p:nvPr/>
         </p:nvSpPr>
@@ -1121,7 +1121,7 @@
       </p:sp>
       <p:sp>
         <p:nvSpPr>
-          <p:cNvPr id="9" name="Shape 9"/>
+          <p:cNvPr id="358" name="Shape 358"/>
           <p:cNvSpPr/>
           <p:nvPr/>
         </p:nvSpPr>
@@ -1155,15 +1155,15 @@
                 <a:latin typeface="Noto Sans SC"/>
                 <a:ea typeface="Noto Sans SC"/>
               </a:rPr>
-              <a:t>89.9792 / 90</a:t>
-            </a:r>
-            <a:endParaRPr lang="en-US"/>
-          </a:p>
-        </p:txBody>
-      </p:sp>
-      <p:sp>
-        <p:nvSpPr>
-          <p:cNvPr id="10" name="Shape 10"/>
+              <a:t>89.9899 / 90</a:t>
+            </a:r>
+            <a:endParaRPr lang="en-US"/>
+          </a:p>
+        </p:txBody>
+      </p:sp>
+      <p:sp>
+        <p:nvSpPr>
+          <p:cNvPr id="359" name="Shape 359"/>
           <p:cNvSpPr/>
           <p:nvPr/>
         </p:nvSpPr>
@@ -1247,7 +1247,7 @@
       </p:sp>
       <p:sp>
         <p:nvSpPr>
-          <p:cNvPr id="11" name="Shape 11"/>
+          <p:cNvPr id="360" name="Shape 360"/>
           <p:cNvSpPr/>
           <p:nvPr/>
         </p:nvSpPr>
@@ -1310,7 +1310,7 @@
       </p:sp>
       <p:pic>
         <p:nvPicPr>
-          <p:cNvPr id="103" name="Presenton Native Image 4" descr=""/>
+          <p:cNvPr id="107" name="Presenton Native Image 4" descr=""/>
           <p:cNvPicPr/>
           <p:nvPr/>
         </p:nvPicPr>
@@ -1332,7 +1332,7 @@
       </p:pic>
       <p:sp>
         <p:nvSpPr>
-          <p:cNvPr id="12" name="Shape 12"/>
+          <p:cNvPr id="361" name="Shape 361"/>
           <p:cNvSpPr/>
           <p:nvPr/>
         </p:nvSpPr>
@@ -1374,7 +1374,7 @@
       </p:sp>
       <p:sp>
         <p:nvSpPr>
-          <p:cNvPr id="13" name="Shape 13"/>
+          <p:cNvPr id="362" name="Shape 362"/>
           <p:cNvSpPr/>
           <p:nvPr/>
         </p:nvSpPr>
@@ -1448,7 +1448,7 @@
       </p:grpSpPr>
       <p:pic>
         <p:nvPicPr>
-          <p:cNvPr id="131" name="Presenton Native Image 32" descr=""/>
+          <p:cNvPr id="135" name="Presenton Native Image 32" descr=""/>
           <p:cNvPicPr/>
           <p:nvPr/>
         </p:nvPicPr>
@@ -1470,7 +1470,7 @@
       </p:pic>
       <p:sp>
         <p:nvSpPr>
-          <p:cNvPr id="77" name="Shape 77"/>
+          <p:cNvPr id="426" name="Shape 426"/>
           <p:cNvSpPr/>
           <p:nvPr/>
         </p:nvSpPr>
@@ -1512,7 +1512,7 @@
       </p:sp>
       <p:sp>
         <p:nvSpPr>
-          <p:cNvPr id="78" name="Shape 78"/>
+          <p:cNvPr id="427" name="Shape 427"/>
           <p:cNvSpPr/>
           <p:nvPr/>
         </p:nvSpPr>
@@ -1554,7 +1554,7 @@
       </p:sp>
       <p:sp>
         <p:nvSpPr>
-          <p:cNvPr id="79" name="Shape 79"/>
+          <p:cNvPr id="428" name="Shape 428"/>
           <p:cNvSpPr/>
           <p:nvPr/>
         </p:nvSpPr>
@@ -1596,7 +1596,7 @@
       </p:sp>
       <p:pic>
         <p:nvPicPr>
-          <p:cNvPr id="132" name="Presenton Native Image 33" descr=""/>
+          <p:cNvPr id="136" name="Presenton Native Image 33" descr=""/>
           <p:cNvPicPr/>
           <p:nvPr/>
         </p:nvPicPr>
@@ -1618,7 +1618,7 @@
       </p:pic>
       <p:sp>
         <p:nvSpPr>
-          <p:cNvPr id="80" name="Shape 80"/>
+          <p:cNvPr id="429" name="Shape 429"/>
           <p:cNvSpPr/>
           <p:nvPr/>
         </p:nvSpPr>
@@ -1660,7 +1660,7 @@
       </p:sp>
       <p:sp>
         <p:nvSpPr>
-          <p:cNvPr id="81" name="Shape 81"/>
+          <p:cNvPr id="430" name="Shape 430"/>
           <p:cNvSpPr/>
           <p:nvPr/>
         </p:nvSpPr>
@@ -1694,15 +1694,15 @@
                 <a:latin typeface="Noto Sans SC"/>
                 <a:ea typeface="Noto Sans SC"/>
               </a:rPr>
-              <a:t>116项检查</a:t>
-            </a:r>
-            <a:endParaRPr lang="en-US"/>
-          </a:p>
-        </p:txBody>
-      </p:sp>
-      <p:sp>
-        <p:nvSpPr>
-          <p:cNvPr id="82" name="Shape 82"/>
+              <a:t>135项检查</a:t>
+            </a:r>
+            <a:endParaRPr lang="en-US"/>
+          </a:p>
+        </p:txBody>
+      </p:sp>
+      <p:sp>
+        <p:nvSpPr>
+          <p:cNvPr id="431" name="Shape 431"/>
           <p:cNvSpPr/>
           <p:nvPr/>
         </p:nvSpPr>
@@ -1757,7 +1757,7 @@
                 <a:latin typeface="Noto Sans SC"/>
                 <a:ea typeface="Noto Sans SC"/>
               </a:rPr>
-              <a:t>+ 4评分失败门禁</a:t>
+              <a:t>+ 19准入 + 4门禁</a:t>
             </a:r>
             <a:r>
               <a:rPr sz="1725" b="0" i="0">
@@ -1786,7 +1786,7 @@
       </p:sp>
       <p:pic>
         <p:nvPicPr>
-          <p:cNvPr id="133" name="Presenton Native Image 34" descr=""/>
+          <p:cNvPr id="137" name="Presenton Native Image 34" descr=""/>
           <p:cNvPicPr/>
           <p:nvPr/>
         </p:nvPicPr>
@@ -1808,7 +1808,7 @@
       </p:pic>
       <p:sp>
         <p:nvSpPr>
-          <p:cNvPr id="83" name="Shape 83"/>
+          <p:cNvPr id="432" name="Shape 432"/>
           <p:cNvSpPr/>
           <p:nvPr/>
         </p:nvSpPr>
@@ -1850,7 +1850,7 @@
       </p:sp>
       <p:sp>
         <p:nvSpPr>
-          <p:cNvPr id="84" name="Shape 84"/>
+          <p:cNvPr id="433" name="Shape 433"/>
           <p:cNvSpPr/>
           <p:nvPr/>
         </p:nvSpPr>
@@ -1892,7 +1892,7 @@
       </p:sp>
       <p:sp>
         <p:nvSpPr>
-          <p:cNvPr id="85" name="Shape 85"/>
+          <p:cNvPr id="434" name="Shape 434"/>
           <p:cNvSpPr/>
           <p:nvPr/>
         </p:nvSpPr>
@@ -1976,7 +1976,7 @@
       </p:sp>
       <p:pic>
         <p:nvPicPr>
-          <p:cNvPr id="134" name="Presenton Native Image 35" descr=""/>
+          <p:cNvPr id="138" name="Presenton Native Image 35" descr=""/>
           <p:cNvPicPr/>
           <p:nvPr/>
         </p:nvPicPr>
@@ -1998,7 +1998,7 @@
       </p:pic>
       <p:sp>
         <p:nvSpPr>
-          <p:cNvPr id="86" name="Shape 86"/>
+          <p:cNvPr id="435" name="Shape 435"/>
           <p:cNvSpPr/>
           <p:nvPr/>
         </p:nvSpPr>
@@ -2040,7 +2040,7 @@
       </p:sp>
       <p:sp>
         <p:nvSpPr>
-          <p:cNvPr id="87" name="Shape 87"/>
+          <p:cNvPr id="436" name="Shape 436"/>
           <p:cNvSpPr/>
           <p:nvPr/>
         </p:nvSpPr>
@@ -2074,15 +2074,15 @@
                 <a:latin typeface="Noto Sans SC"/>
                 <a:ea typeface="Noto Sans SC"/>
               </a:rPr>
-              <a:t>1.32秒</a:t>
-            </a:r>
-            <a:endParaRPr lang="en-US"/>
-          </a:p>
-        </p:txBody>
-      </p:sp>
-      <p:sp>
-        <p:nvSpPr>
-          <p:cNvPr id="88" name="Shape 88"/>
+              <a:t>1.26秒</a:t>
+            </a:r>
+            <a:endParaRPr lang="en-US"/>
+          </a:p>
+        </p:txBody>
+      </p:sp>
+      <p:sp>
+        <p:nvSpPr>
+          <p:cNvPr id="437" name="Shape 437"/>
           <p:cNvSpPr/>
           <p:nvPr/>
         </p:nvSpPr>
@@ -2158,15 +2158,15 @@
                 <a:latin typeface="Noto Sans SC"/>
                 <a:ea typeface="Noto Sans SC"/>
               </a:rPr>
-              <a:t>profile峰值内存2.82GiB</a:t>
-            </a:r>
-            <a:endParaRPr lang="en-US"/>
-          </a:p>
-        </p:txBody>
-      </p:sp>
-      <p:sp>
-        <p:nvSpPr>
-          <p:cNvPr id="89" name="Shape 89"/>
+              <a:t>profile峰值内存2.57GiB</a:t>
+            </a:r>
+            <a:endParaRPr lang="en-US"/>
+          </a:p>
+        </p:txBody>
+      </p:sp>
+      <p:sp>
+        <p:nvSpPr>
+          <p:cNvPr id="438" name="Shape 438"/>
           <p:cNvSpPr/>
           <p:nvPr/>
         </p:nvSpPr>
@@ -2208,7 +2208,7 @@
       </p:sp>
       <p:pic>
         <p:nvPicPr>
-          <p:cNvPr id="135" name="Presenton Native Image 36" descr=""/>
+          <p:cNvPr id="139" name="Presenton Native Image 36" descr=""/>
           <p:cNvPicPr/>
           <p:nvPr/>
         </p:nvPicPr>
@@ -2230,7 +2230,7 @@
       </p:pic>
       <p:sp>
         <p:nvSpPr>
-          <p:cNvPr id="90" name="Shape 90"/>
+          <p:cNvPr id="439" name="Shape 439"/>
           <p:cNvSpPr/>
           <p:nvPr/>
         </p:nvSpPr>
@@ -2272,7 +2272,7 @@
       </p:sp>
       <p:sp>
         <p:nvSpPr>
-          <p:cNvPr id="91" name="Shape 91"/>
+          <p:cNvPr id="440" name="Shape 440"/>
           <p:cNvSpPr/>
           <p:nvPr/>
         </p:nvSpPr>
@@ -2346,7 +2346,7 @@
       </p:grpSpPr>
       <p:pic>
         <p:nvPicPr>
-          <p:cNvPr id="136" name="Presenton Native Image 37" descr=""/>
+          <p:cNvPr id="140" name="Presenton Native Image 37" descr=""/>
           <p:cNvPicPr/>
           <p:nvPr/>
         </p:nvPicPr>
@@ -2368,7 +2368,7 @@
       </p:pic>
       <p:sp>
         <p:nvSpPr>
-          <p:cNvPr id="92" name="Shape 92"/>
+          <p:cNvPr id="441" name="Shape 441"/>
           <p:cNvSpPr/>
           <p:nvPr/>
         </p:nvSpPr>
@@ -2410,7 +2410,7 @@
       </p:sp>
       <p:sp>
         <p:nvSpPr>
-          <p:cNvPr id="93" name="Shape 93"/>
+          <p:cNvPr id="442" name="Shape 442"/>
           <p:cNvSpPr/>
           <p:nvPr/>
         </p:nvSpPr>
@@ -2452,7 +2452,7 @@
       </p:sp>
       <p:sp>
         <p:nvSpPr>
-          <p:cNvPr id="94" name="Shape 94"/>
+          <p:cNvPr id="443" name="Shape 443"/>
           <p:cNvSpPr/>
           <p:nvPr/>
         </p:nvSpPr>
@@ -2494,7 +2494,7 @@
       </p:sp>
       <p:pic>
         <p:nvPicPr>
-          <p:cNvPr id="137" name="Presenton Native Image 38" descr=""/>
+          <p:cNvPr id="141" name="Presenton Native Image 38" descr=""/>
           <p:cNvPicPr/>
           <p:nvPr/>
         </p:nvPicPr>
@@ -2516,7 +2516,7 @@
       </p:pic>
       <p:sp>
         <p:nvSpPr>
-          <p:cNvPr id="95" name="Shape 95"/>
+          <p:cNvPr id="444" name="Shape 444"/>
           <p:cNvSpPr/>
           <p:nvPr/>
         </p:nvSpPr>
@@ -2558,7 +2558,7 @@
       </p:sp>
       <p:sp>
         <p:nvSpPr>
-          <p:cNvPr id="96" name="Shape 96"/>
+          <p:cNvPr id="445" name="Shape 445"/>
           <p:cNvSpPr/>
           <p:nvPr/>
         </p:nvSpPr>
@@ -2600,7 +2600,7 @@
       </p:sp>
       <p:sp>
         <p:nvSpPr>
-          <p:cNvPr id="97" name="Shape 97"/>
+          <p:cNvPr id="446" name="Shape 446"/>
           <p:cNvSpPr/>
           <p:nvPr/>
         </p:nvSpPr>
@@ -2684,7 +2684,7 @@
       </p:sp>
       <p:pic>
         <p:nvPicPr>
-          <p:cNvPr id="138" name="Presenton Native Image 39" descr=""/>
+          <p:cNvPr id="142" name="Presenton Native Image 39" descr=""/>
           <p:cNvPicPr/>
           <p:nvPr/>
         </p:nvPicPr>
@@ -2706,7 +2706,7 @@
       </p:pic>
       <p:sp>
         <p:nvSpPr>
-          <p:cNvPr id="98" name="Shape 98"/>
+          <p:cNvPr id="447" name="Shape 447"/>
           <p:cNvSpPr/>
           <p:nvPr/>
         </p:nvSpPr>
@@ -2748,7 +2748,7 @@
       </p:sp>
       <p:sp>
         <p:nvSpPr>
-          <p:cNvPr id="99" name="Shape 99"/>
+          <p:cNvPr id="448" name="Shape 448"/>
           <p:cNvSpPr/>
           <p:nvPr/>
         </p:nvSpPr>
@@ -2790,7 +2790,7 @@
       </p:sp>
       <p:sp>
         <p:nvSpPr>
-          <p:cNvPr id="100" name="Shape 100"/>
+          <p:cNvPr id="449" name="Shape 449"/>
           <p:cNvSpPr/>
           <p:nvPr/>
         </p:nvSpPr>
@@ -2874,7 +2874,7 @@
       </p:sp>
       <p:pic>
         <p:nvPicPr>
-          <p:cNvPr id="139" name="Presenton Native Image 40" descr=""/>
+          <p:cNvPr id="143" name="Presenton Native Image 40" descr=""/>
           <p:cNvPicPr/>
           <p:nvPr/>
         </p:nvPicPr>
@@ -2896,7 +2896,7 @@
       </p:pic>
       <p:sp>
         <p:nvSpPr>
-          <p:cNvPr id="101" name="Shape 101"/>
+          <p:cNvPr id="450" name="Shape 450"/>
           <p:cNvSpPr/>
           <p:nvPr/>
         </p:nvSpPr>
@@ -2938,7 +2938,7 @@
       </p:sp>
       <p:sp>
         <p:nvSpPr>
-          <p:cNvPr id="102" name="Shape 102"/>
+          <p:cNvPr id="451" name="Shape 451"/>
           <p:cNvSpPr/>
           <p:nvPr/>
         </p:nvSpPr>
@@ -2980,7 +2980,7 @@
       </p:sp>
       <p:sp>
         <p:nvSpPr>
-          <p:cNvPr id="103" name="Shape 103"/>
+          <p:cNvPr id="452" name="Shape 452"/>
           <p:cNvSpPr/>
           <p:nvPr/>
         </p:nvSpPr>
@@ -3064,7 +3064,7 @@
       </p:sp>
       <p:sp>
         <p:nvSpPr>
-          <p:cNvPr id="104" name="Shape 104"/>
+          <p:cNvPr id="453" name="Shape 453"/>
           <p:cNvSpPr/>
           <p:nvPr/>
         </p:nvSpPr>
@@ -3127,7 +3127,7 @@
       </p:sp>
       <p:pic>
         <p:nvPicPr>
-          <p:cNvPr id="140" name="Presenton Native Image 41" descr=""/>
+          <p:cNvPr id="144" name="Presenton Native Image 41" descr=""/>
           <p:cNvPicPr/>
           <p:nvPr/>
         </p:nvPicPr>
@@ -3149,7 +3149,7 @@
       </p:pic>
       <p:sp>
         <p:nvSpPr>
-          <p:cNvPr id="105" name="Shape 105"/>
+          <p:cNvPr id="454" name="Shape 454"/>
           <p:cNvSpPr/>
           <p:nvPr/>
         </p:nvSpPr>
@@ -3191,7 +3191,7 @@
       </p:sp>
       <p:sp>
         <p:nvSpPr>
-          <p:cNvPr id="106" name="Shape 106"/>
+          <p:cNvPr id="455" name="Shape 455"/>
           <p:cNvSpPr/>
           <p:nvPr/>
         </p:nvSpPr>
@@ -3265,7 +3265,7 @@
       </p:grpSpPr>
       <p:pic>
         <p:nvPicPr>
-          <p:cNvPr id="141" name="Presenton Native Image 42" descr=""/>
+          <p:cNvPr id="145" name="Presenton Native Image 42" descr=""/>
           <p:cNvPicPr/>
           <p:nvPr/>
         </p:nvPicPr>
@@ -3287,7 +3287,7 @@
       </p:pic>
       <p:sp>
         <p:nvSpPr>
-          <p:cNvPr id="107" name="Shape 107"/>
+          <p:cNvPr id="456" name="Shape 456"/>
           <p:cNvSpPr/>
           <p:nvPr/>
         </p:nvSpPr>
@@ -3329,7 +3329,7 @@
       </p:sp>
       <p:sp>
         <p:nvSpPr>
-          <p:cNvPr id="108" name="Shape 108"/>
+          <p:cNvPr id="457" name="Shape 457"/>
           <p:cNvSpPr/>
           <p:nvPr/>
         </p:nvSpPr>
@@ -3371,7 +3371,7 @@
       </p:sp>
       <p:sp>
         <p:nvSpPr>
-          <p:cNvPr id="109" name="Shape 109"/>
+          <p:cNvPr id="458" name="Shape 458"/>
           <p:cNvSpPr/>
           <p:nvPr/>
         </p:nvSpPr>
@@ -3413,7 +3413,7 @@
       </p:sp>
       <p:pic>
         <p:nvPicPr>
-          <p:cNvPr id="142" name="Presenton Native Image 43" descr=""/>
+          <p:cNvPr id="146" name="Presenton Native Image 43" descr=""/>
           <p:cNvPicPr/>
           <p:nvPr/>
         </p:nvPicPr>
@@ -3426,7 +3426,7 @@
         <p:spPr>
           <a:xfrm>
             <a:off x="571500" y="1728788"/>
-            <a:ext cx="11049000" cy="3762375"/>
+            <a:ext cx="11049000" cy="2676525"/>
           </a:xfrm>
           <a:prstGeom prst="rect">
             <a:avLst/>
@@ -3435,13 +3435,13 @@
       </p:pic>
       <p:sp>
         <p:nvSpPr>
-          <p:cNvPr id="110" name="Shape 110"/>
-          <p:cNvSpPr/>
-          <p:nvPr/>
-        </p:nvSpPr>
-        <p:spPr>
-          <a:xfrm>
-            <a:off x="571500" y="5681663"/>
+          <p:cNvPr id="459" name="Shape 459"/>
+          <p:cNvSpPr/>
+          <p:nvPr/>
+        </p:nvSpPr>
+        <p:spPr>
+          <a:xfrm>
+            <a:off x="571500" y="4595813"/>
             <a:ext cx="11068050" cy="657225"/>
           </a:xfrm>
           <a:prstGeom prst="rect">
@@ -3498,7 +3498,7 @@
       </p:sp>
       <p:pic>
         <p:nvPicPr>
-          <p:cNvPr id="143" name="Presenton Native Image 44" descr=""/>
+          <p:cNvPr id="147" name="Presenton Native Image 44" descr=""/>
           <p:cNvPicPr/>
           <p:nvPr/>
         </p:nvPicPr>
@@ -3520,7 +3520,7 @@
       </p:pic>
       <p:sp>
         <p:nvSpPr>
-          <p:cNvPr id="111" name="Shape 111"/>
+          <p:cNvPr id="460" name="Shape 460"/>
           <p:cNvSpPr/>
           <p:nvPr/>
         </p:nvSpPr>
@@ -3562,7 +3562,7 @@
       </p:sp>
       <p:sp>
         <p:nvSpPr>
-          <p:cNvPr id="112" name="Shape 112"/>
+          <p:cNvPr id="461" name="Shape 461"/>
           <p:cNvSpPr/>
           <p:nvPr/>
         </p:nvSpPr>
@@ -3636,7 +3636,7 @@
       </p:grpSpPr>
       <p:pic>
         <p:nvPicPr>
-          <p:cNvPr id="104" name="Presenton Native Image 5" descr=""/>
+          <p:cNvPr id="108" name="Presenton Native Image 5" descr=""/>
           <p:cNvPicPr/>
           <p:nvPr/>
         </p:nvPicPr>
@@ -3658,7 +3658,7 @@
       </p:pic>
       <p:sp>
         <p:nvSpPr>
-          <p:cNvPr id="14" name="Shape 14"/>
+          <p:cNvPr id="363" name="Shape 363"/>
           <p:cNvSpPr/>
           <p:nvPr/>
         </p:nvSpPr>
@@ -3700,7 +3700,7 @@
       </p:sp>
       <p:sp>
         <p:nvSpPr>
-          <p:cNvPr id="15" name="Shape 15"/>
+          <p:cNvPr id="364" name="Shape 364"/>
           <p:cNvSpPr/>
           <p:nvPr/>
         </p:nvSpPr>
@@ -3742,7 +3742,7 @@
       </p:sp>
       <p:sp>
         <p:nvSpPr>
-          <p:cNvPr id="16" name="Shape 16"/>
+          <p:cNvPr id="365" name="Shape 365"/>
           <p:cNvSpPr/>
           <p:nvPr/>
         </p:nvSpPr>
@@ -3784,7 +3784,7 @@
       </p:sp>
       <p:pic>
         <p:nvPicPr>
-          <p:cNvPr id="105" name="Presenton Native Image 6" descr=""/>
+          <p:cNvPr id="109" name="Presenton Native Image 6" descr=""/>
           <p:cNvPicPr/>
           <p:nvPr/>
         </p:nvPicPr>
@@ -3797,7 +3797,7 @@
         <p:spPr>
           <a:xfrm>
             <a:off x="571500" y="1728788"/>
-            <a:ext cx="11049000" cy="3133725"/>
+            <a:ext cx="11049000" cy="2228850"/>
           </a:xfrm>
           <a:prstGeom prst="rect">
             <a:avLst/>
@@ -3806,13 +3806,13 @@
       </p:pic>
       <p:sp>
         <p:nvSpPr>
-          <p:cNvPr id="17" name="Shape 17"/>
-          <p:cNvSpPr/>
-          <p:nvPr/>
-        </p:nvSpPr>
-        <p:spPr>
-          <a:xfrm>
-            <a:off x="571500" y="5091113"/>
+          <p:cNvPr id="366" name="Shape 366"/>
+          <p:cNvSpPr/>
+          <p:nvPr/>
+        </p:nvSpPr>
+        <p:spPr>
+          <a:xfrm>
+            <a:off x="571500" y="4186238"/>
             <a:ext cx="11068050" cy="714375"/>
           </a:xfrm>
           <a:prstGeom prst="rect">
@@ -3869,7 +3869,7 @@
       </p:sp>
       <p:pic>
         <p:nvPicPr>
-          <p:cNvPr id="106" name="Presenton Native Image 7" descr=""/>
+          <p:cNvPr id="110" name="Presenton Native Image 7" descr=""/>
           <p:cNvPicPr/>
           <p:nvPr/>
         </p:nvPicPr>
@@ -3891,7 +3891,7 @@
       </p:pic>
       <p:sp>
         <p:nvSpPr>
-          <p:cNvPr id="18" name="Shape 18"/>
+          <p:cNvPr id="367" name="Shape 367"/>
           <p:cNvSpPr/>
           <p:nvPr/>
         </p:nvSpPr>
@@ -3933,7 +3933,7 @@
       </p:sp>
       <p:sp>
         <p:nvSpPr>
-          <p:cNvPr id="19" name="Shape 19"/>
+          <p:cNvPr id="368" name="Shape 368"/>
           <p:cNvSpPr/>
           <p:nvPr/>
         </p:nvSpPr>
@@ -4007,7 +4007,7 @@
       </p:grpSpPr>
       <p:pic>
         <p:nvPicPr>
-          <p:cNvPr id="107" name="Presenton Native Image 8" descr=""/>
+          <p:cNvPr id="111" name="Presenton Native Image 8" descr=""/>
           <p:cNvPicPr/>
           <p:nvPr/>
         </p:nvPicPr>
@@ -4029,7 +4029,7 @@
       </p:pic>
       <p:sp>
         <p:nvSpPr>
-          <p:cNvPr id="20" name="Shape 20"/>
+          <p:cNvPr id="369" name="Shape 369"/>
           <p:cNvSpPr/>
           <p:nvPr/>
         </p:nvSpPr>
@@ -4071,7 +4071,7 @@
       </p:sp>
       <p:sp>
         <p:nvSpPr>
-          <p:cNvPr id="21" name="Shape 21"/>
+          <p:cNvPr id="370" name="Shape 370"/>
           <p:cNvSpPr/>
           <p:nvPr/>
         </p:nvSpPr>
@@ -4113,7 +4113,7 @@
       </p:sp>
       <p:sp>
         <p:nvSpPr>
-          <p:cNvPr id="22" name="Shape 22"/>
+          <p:cNvPr id="371" name="Shape 371"/>
           <p:cNvSpPr/>
           <p:nvPr/>
         </p:nvSpPr>
@@ -4155,7 +4155,7 @@
       </p:sp>
       <p:pic>
         <p:nvPicPr>
-          <p:cNvPr id="108" name="Presenton Native Image 9" descr=""/>
+          <p:cNvPr id="112" name="Presenton Native Image 9" descr=""/>
           <p:cNvPicPr/>
           <p:nvPr/>
         </p:nvPicPr>
@@ -4168,7 +4168,7 @@
         <p:spPr>
           <a:xfrm>
             <a:off x="571500" y="1728788"/>
-            <a:ext cx="11049000" cy="3133725"/>
+            <a:ext cx="11049000" cy="2228850"/>
           </a:xfrm>
           <a:prstGeom prst="rect">
             <a:avLst/>
@@ -4177,13 +4177,13 @@
       </p:pic>
       <p:sp>
         <p:nvSpPr>
-          <p:cNvPr id="23" name="Shape 23"/>
-          <p:cNvSpPr/>
-          <p:nvPr/>
-        </p:nvSpPr>
-        <p:spPr>
-          <a:xfrm>
-            <a:off x="571500" y="5091113"/>
+          <p:cNvPr id="372" name="Shape 372"/>
+          <p:cNvSpPr/>
+          <p:nvPr/>
+        </p:nvSpPr>
+        <p:spPr>
+          <a:xfrm>
+            <a:off x="571500" y="4186238"/>
             <a:ext cx="11068050" cy="385763"/>
           </a:xfrm>
           <a:prstGeom prst="rect">
@@ -4219,7 +4219,7 @@
       </p:sp>
       <p:pic>
         <p:nvPicPr>
-          <p:cNvPr id="109" name="Presenton Native Image 10" descr=""/>
+          <p:cNvPr id="113" name="Presenton Native Image 10" descr=""/>
           <p:cNvPicPr/>
           <p:nvPr/>
         </p:nvPicPr>
@@ -4241,7 +4241,7 @@
       </p:pic>
       <p:sp>
         <p:nvSpPr>
-          <p:cNvPr id="24" name="Shape 24"/>
+          <p:cNvPr id="373" name="Shape 373"/>
           <p:cNvSpPr/>
           <p:nvPr/>
         </p:nvSpPr>
@@ -4283,7 +4283,7 @@
       </p:sp>
       <p:sp>
         <p:nvSpPr>
-          <p:cNvPr id="25" name="Shape 25"/>
+          <p:cNvPr id="374" name="Shape 374"/>
           <p:cNvSpPr/>
           <p:nvPr/>
         </p:nvSpPr>
@@ -4357,7 +4357,7 @@
       </p:grpSpPr>
       <p:pic>
         <p:nvPicPr>
-          <p:cNvPr id="110" name="Presenton Native Image 11" descr=""/>
+          <p:cNvPr id="114" name="Presenton Native Image 11" descr=""/>
           <p:cNvPicPr/>
           <p:nvPr/>
         </p:nvPicPr>
@@ -4379,7 +4379,7 @@
       </p:pic>
       <p:sp>
         <p:nvSpPr>
-          <p:cNvPr id="26" name="Shape 26"/>
+          <p:cNvPr id="375" name="Shape 375"/>
           <p:cNvSpPr/>
           <p:nvPr/>
         </p:nvSpPr>
@@ -4421,7 +4421,7 @@
       </p:sp>
       <p:sp>
         <p:nvSpPr>
-          <p:cNvPr id="27" name="Shape 27"/>
+          <p:cNvPr id="376" name="Shape 376"/>
           <p:cNvSpPr/>
           <p:nvPr/>
         </p:nvSpPr>
@@ -4463,7 +4463,7 @@
       </p:sp>
       <p:sp>
         <p:nvSpPr>
-          <p:cNvPr id="28" name="Shape 28"/>
+          <p:cNvPr id="377" name="Shape 377"/>
           <p:cNvSpPr/>
           <p:nvPr/>
         </p:nvSpPr>
@@ -4505,7 +4505,7 @@
       </p:sp>
       <p:pic>
         <p:nvPicPr>
-          <p:cNvPr id="111" name="Presenton Native Image 12" descr=""/>
+          <p:cNvPr id="115" name="Presenton Native Image 12" descr=""/>
           <p:cNvPicPr/>
           <p:nvPr/>
         </p:nvPicPr>
@@ -4527,7 +4527,7 @@
       </p:pic>
       <p:sp>
         <p:nvSpPr>
-          <p:cNvPr id="29" name="Shape 29"/>
+          <p:cNvPr id="378" name="Shape 378"/>
           <p:cNvSpPr/>
           <p:nvPr/>
         </p:nvSpPr>
@@ -4569,7 +4569,7 @@
       </p:sp>
       <p:sp>
         <p:nvSpPr>
-          <p:cNvPr id="30" name="Shape 30"/>
+          <p:cNvPr id="379" name="Shape 379"/>
           <p:cNvSpPr/>
           <p:nvPr/>
         </p:nvSpPr>
@@ -4611,7 +4611,7 @@
       </p:sp>
       <p:sp>
         <p:nvSpPr>
-          <p:cNvPr id="31" name="Shape 31"/>
+          <p:cNvPr id="380" name="Shape 380"/>
           <p:cNvSpPr/>
           <p:nvPr/>
         </p:nvSpPr>
@@ -4695,7 +4695,7 @@
       </p:sp>
       <p:pic>
         <p:nvPicPr>
-          <p:cNvPr id="112" name="Presenton Native Image 13" descr=""/>
+          <p:cNvPr id="116" name="Presenton Native Image 13" descr=""/>
           <p:cNvPicPr/>
           <p:nvPr/>
         </p:nvPicPr>
@@ -4717,7 +4717,7 @@
       </p:pic>
       <p:sp>
         <p:nvSpPr>
-          <p:cNvPr id="32" name="Shape 32"/>
+          <p:cNvPr id="381" name="Shape 381"/>
           <p:cNvSpPr/>
           <p:nvPr/>
         </p:nvSpPr>
@@ -4759,7 +4759,7 @@
       </p:sp>
       <p:sp>
         <p:nvSpPr>
-          <p:cNvPr id="33" name="Shape 33"/>
+          <p:cNvPr id="382" name="Shape 382"/>
           <p:cNvSpPr/>
           <p:nvPr/>
         </p:nvSpPr>
@@ -4801,7 +4801,7 @@
       </p:sp>
       <p:sp>
         <p:nvSpPr>
-          <p:cNvPr id="34" name="Shape 34"/>
+          <p:cNvPr id="383" name="Shape 383"/>
           <p:cNvSpPr/>
           <p:nvPr/>
         </p:nvSpPr>
@@ -4885,7 +4885,7 @@
       </p:sp>
       <p:pic>
         <p:nvPicPr>
-          <p:cNvPr id="113" name="Presenton Native Image 14" descr=""/>
+          <p:cNvPr id="117" name="Presenton Native Image 14" descr=""/>
           <p:cNvPicPr/>
           <p:nvPr/>
         </p:nvPicPr>
@@ -4907,7 +4907,7 @@
       </p:pic>
       <p:sp>
         <p:nvSpPr>
-          <p:cNvPr id="35" name="Shape 35"/>
+          <p:cNvPr id="384" name="Shape 384"/>
           <p:cNvSpPr/>
           <p:nvPr/>
         </p:nvSpPr>
@@ -4949,7 +4949,7 @@
       </p:sp>
       <p:sp>
         <p:nvSpPr>
-          <p:cNvPr id="36" name="Shape 36"/>
+          <p:cNvPr id="385" name="Shape 385"/>
           <p:cNvSpPr/>
           <p:nvPr/>
         </p:nvSpPr>
@@ -4991,7 +4991,7 @@
       </p:sp>
       <p:sp>
         <p:nvSpPr>
-          <p:cNvPr id="37" name="Shape 37"/>
+          <p:cNvPr id="386" name="Shape 386"/>
           <p:cNvSpPr/>
           <p:nvPr/>
         </p:nvSpPr>
@@ -5075,7 +5075,7 @@
       </p:sp>
       <p:sp>
         <p:nvSpPr>
-          <p:cNvPr id="38" name="Shape 38"/>
+          <p:cNvPr id="387" name="Shape 387"/>
           <p:cNvSpPr/>
           <p:nvPr/>
         </p:nvSpPr>
@@ -5117,7 +5117,7 @@
       </p:sp>
       <p:pic>
         <p:nvPicPr>
-          <p:cNvPr id="114" name="Presenton Native Image 15" descr=""/>
+          <p:cNvPr id="118" name="Presenton Native Image 15" descr=""/>
           <p:cNvPicPr/>
           <p:nvPr/>
         </p:nvPicPr>
@@ -5139,7 +5139,7 @@
       </p:pic>
       <p:sp>
         <p:nvSpPr>
-          <p:cNvPr id="39" name="Shape 39"/>
+          <p:cNvPr id="388" name="Shape 388"/>
           <p:cNvSpPr/>
           <p:nvPr/>
         </p:nvSpPr>
@@ -5181,7 +5181,7 @@
       </p:sp>
       <p:sp>
         <p:nvSpPr>
-          <p:cNvPr id="40" name="Shape 40"/>
+          <p:cNvPr id="389" name="Shape 389"/>
           <p:cNvSpPr/>
           <p:nvPr/>
         </p:nvSpPr>
@@ -5255,7 +5255,7 @@
       </p:grpSpPr>
       <p:pic>
         <p:nvPicPr>
-          <p:cNvPr id="115" name="Presenton Native Image 16" descr=""/>
+          <p:cNvPr id="119" name="Presenton Native Image 16" descr=""/>
           <p:cNvPicPr/>
           <p:nvPr/>
         </p:nvPicPr>
@@ -5277,7 +5277,7 @@
       </p:pic>
       <p:sp>
         <p:nvSpPr>
-          <p:cNvPr id="41" name="Shape 41"/>
+          <p:cNvPr id="390" name="Shape 390"/>
           <p:cNvSpPr/>
           <p:nvPr/>
         </p:nvSpPr>
@@ -5319,7 +5319,7 @@
       </p:sp>
       <p:sp>
         <p:nvSpPr>
-          <p:cNvPr id="42" name="Shape 42"/>
+          <p:cNvPr id="391" name="Shape 391"/>
           <p:cNvSpPr/>
           <p:nvPr/>
         </p:nvSpPr>
@@ -5361,7 +5361,7 @@
       </p:sp>
       <p:sp>
         <p:nvSpPr>
-          <p:cNvPr id="43" name="Shape 43"/>
+          <p:cNvPr id="392" name="Shape 392"/>
           <p:cNvSpPr/>
           <p:nvPr/>
         </p:nvSpPr>
@@ -5403,7 +5403,7 @@
       </p:sp>
       <p:pic>
         <p:nvPicPr>
-          <p:cNvPr id="116" name="Presenton Native Image 17" descr=""/>
+          <p:cNvPr id="120" name="Presenton Native Image 17" descr=""/>
           <p:cNvPicPr/>
           <p:nvPr/>
         </p:nvPicPr>
@@ -5416,7 +5416,7 @@
         <p:spPr>
           <a:xfrm>
             <a:off x="571500" y="1728788"/>
-            <a:ext cx="11049000" cy="3133725"/>
+            <a:ext cx="11049000" cy="2228850"/>
           </a:xfrm>
           <a:prstGeom prst="rect">
             <a:avLst/>
@@ -5425,13 +5425,13 @@
       </p:pic>
       <p:sp>
         <p:nvSpPr>
-          <p:cNvPr id="44" name="Shape 44"/>
-          <p:cNvSpPr/>
-          <p:nvPr/>
-        </p:nvSpPr>
-        <p:spPr>
-          <a:xfrm>
-            <a:off x="571500" y="5091113"/>
+          <p:cNvPr id="393" name="Shape 393"/>
+          <p:cNvSpPr/>
+          <p:nvPr/>
+        </p:nvSpPr>
+        <p:spPr>
+          <a:xfrm>
+            <a:off x="571500" y="4186238"/>
             <a:ext cx="11068050" cy="657225"/>
           </a:xfrm>
           <a:prstGeom prst="rect">
@@ -5488,7 +5488,7 @@
       </p:sp>
       <p:pic>
         <p:nvPicPr>
-          <p:cNvPr id="117" name="Presenton Native Image 18" descr=""/>
+          <p:cNvPr id="121" name="Presenton Native Image 18" descr=""/>
           <p:cNvPicPr/>
           <p:nvPr/>
         </p:nvPicPr>
@@ -5510,7 +5510,7 @@
       </p:pic>
       <p:sp>
         <p:nvSpPr>
-          <p:cNvPr id="45" name="Shape 45"/>
+          <p:cNvPr id="394" name="Shape 394"/>
           <p:cNvSpPr/>
           <p:nvPr/>
         </p:nvSpPr>
@@ -5552,7 +5552,7 @@
       </p:sp>
       <p:sp>
         <p:nvSpPr>
-          <p:cNvPr id="46" name="Shape 46"/>
+          <p:cNvPr id="395" name="Shape 395"/>
           <p:cNvSpPr/>
           <p:nvPr/>
         </p:nvSpPr>
@@ -5626,7 +5626,7 @@
       </p:grpSpPr>
       <p:pic>
         <p:nvPicPr>
-          <p:cNvPr id="118" name="Presenton Native Image 19" descr=""/>
+          <p:cNvPr id="122" name="Presenton Native Image 19" descr=""/>
           <p:cNvPicPr/>
           <p:nvPr/>
         </p:nvPicPr>
@@ -5648,7 +5648,7 @@
       </p:pic>
       <p:sp>
         <p:nvSpPr>
-          <p:cNvPr id="47" name="Shape 47"/>
+          <p:cNvPr id="396" name="Shape 396"/>
           <p:cNvSpPr/>
           <p:nvPr/>
         </p:nvSpPr>
@@ -5690,7 +5690,7 @@
       </p:sp>
       <p:sp>
         <p:nvSpPr>
-          <p:cNvPr id="48" name="Shape 48"/>
+          <p:cNvPr id="397" name="Shape 397"/>
           <p:cNvSpPr/>
           <p:nvPr/>
         </p:nvSpPr>
@@ -5732,7 +5732,7 @@
       </p:sp>
       <p:sp>
         <p:nvSpPr>
-          <p:cNvPr id="49" name="Shape 49"/>
+          <p:cNvPr id="398" name="Shape 398"/>
           <p:cNvSpPr/>
           <p:nvPr/>
         </p:nvSpPr>
@@ -5774,7 +5774,7 @@
       </p:sp>
       <p:pic>
         <p:nvPicPr>
-          <p:cNvPr id="119" name="Presenton Native Image 20" descr=""/>
+          <p:cNvPr id="123" name="Presenton Native Image 20" descr=""/>
           <p:cNvPicPr/>
           <p:nvPr/>
         </p:nvPicPr>
@@ -5796,7 +5796,7 @@
       </p:pic>
       <p:sp>
         <p:nvSpPr>
-          <p:cNvPr id="50" name="Shape 50"/>
+          <p:cNvPr id="399" name="Shape 399"/>
           <p:cNvSpPr/>
           <p:nvPr/>
         </p:nvSpPr>
@@ -5838,7 +5838,7 @@
       </p:sp>
       <p:sp>
         <p:nvSpPr>
-          <p:cNvPr id="51" name="Shape 51"/>
+          <p:cNvPr id="400" name="Shape 400"/>
           <p:cNvSpPr/>
           <p:nvPr/>
         </p:nvSpPr>
@@ -5880,7 +5880,7 @@
       </p:sp>
       <p:sp>
         <p:nvSpPr>
-          <p:cNvPr id="52" name="Shape 52"/>
+          <p:cNvPr id="401" name="Shape 401"/>
           <p:cNvSpPr/>
           <p:nvPr/>
         </p:nvSpPr>
@@ -5964,7 +5964,7 @@
       </p:sp>
       <p:pic>
         <p:nvPicPr>
-          <p:cNvPr id="120" name="Presenton Native Image 21" descr=""/>
+          <p:cNvPr id="124" name="Presenton Native Image 21" descr=""/>
           <p:cNvPicPr/>
           <p:nvPr/>
         </p:nvPicPr>
@@ -5986,7 +5986,7 @@
       </p:pic>
       <p:sp>
         <p:nvSpPr>
-          <p:cNvPr id="53" name="Shape 53"/>
+          <p:cNvPr id="402" name="Shape 402"/>
           <p:cNvSpPr/>
           <p:nvPr/>
         </p:nvSpPr>
@@ -6028,7 +6028,7 @@
       </p:sp>
       <p:sp>
         <p:nvSpPr>
-          <p:cNvPr id="54" name="Shape 54"/>
+          <p:cNvPr id="403" name="Shape 403"/>
           <p:cNvSpPr/>
           <p:nvPr/>
         </p:nvSpPr>
@@ -6070,7 +6070,7 @@
       </p:sp>
       <p:sp>
         <p:nvSpPr>
-          <p:cNvPr id="55" name="Shape 55"/>
+          <p:cNvPr id="404" name="Shape 404"/>
           <p:cNvSpPr/>
           <p:nvPr/>
         </p:nvSpPr>
@@ -6154,7 +6154,7 @@
       </p:sp>
       <p:sp>
         <p:nvSpPr>
-          <p:cNvPr id="56" name="Shape 56"/>
+          <p:cNvPr id="405" name="Shape 405"/>
           <p:cNvSpPr/>
           <p:nvPr/>
         </p:nvSpPr>
@@ -6219,7 +6219,7 @@
       </p:sp>
       <p:pic>
         <p:nvPicPr>
-          <p:cNvPr id="121" name="Presenton Native Image 22" descr=""/>
+          <p:cNvPr id="125" name="Presenton Native Image 22" descr=""/>
           <p:cNvPicPr/>
           <p:nvPr/>
         </p:nvPicPr>
@@ -6241,7 +6241,7 @@
       </p:pic>
       <p:sp>
         <p:nvSpPr>
-          <p:cNvPr id="57" name="Shape 57"/>
+          <p:cNvPr id="406" name="Shape 406"/>
           <p:cNvSpPr/>
           <p:nvPr/>
         </p:nvSpPr>
@@ -6283,7 +6283,7 @@
       </p:sp>
       <p:sp>
         <p:nvSpPr>
-          <p:cNvPr id="58" name="Shape 58"/>
+          <p:cNvPr id="407" name="Shape 407"/>
           <p:cNvSpPr/>
           <p:nvPr/>
         </p:nvSpPr>
@@ -6357,7 +6357,7 @@
       </p:grpSpPr>
       <p:pic>
         <p:nvPicPr>
-          <p:cNvPr id="122" name="Presenton Native Image 23" descr=""/>
+          <p:cNvPr id="126" name="Presenton Native Image 23" descr=""/>
           <p:cNvPicPr/>
           <p:nvPr/>
         </p:nvPicPr>
@@ -6379,7 +6379,7 @@
       </p:pic>
       <p:sp>
         <p:nvSpPr>
-          <p:cNvPr id="59" name="Shape 59"/>
+          <p:cNvPr id="408" name="Shape 408"/>
           <p:cNvSpPr/>
           <p:nvPr/>
         </p:nvSpPr>
@@ -6421,7 +6421,7 @@
       </p:sp>
       <p:sp>
         <p:nvSpPr>
-          <p:cNvPr id="60" name="Shape 60"/>
+          <p:cNvPr id="409" name="Shape 409"/>
           <p:cNvSpPr/>
           <p:nvPr/>
         </p:nvSpPr>
@@ -6463,7 +6463,7 @@
       </p:sp>
       <p:sp>
         <p:nvSpPr>
-          <p:cNvPr id="61" name="Shape 61"/>
+          <p:cNvPr id="410" name="Shape 410"/>
           <p:cNvSpPr/>
           <p:nvPr/>
         </p:nvSpPr>
@@ -6505,7 +6505,7 @@
       </p:sp>
       <p:pic>
         <p:nvPicPr>
-          <p:cNvPr id="123" name="Presenton Native Image 24" descr=""/>
+          <p:cNvPr id="127" name="Presenton Native Image 24" descr=""/>
           <p:cNvPicPr/>
           <p:nvPr/>
         </p:nvPicPr>
@@ -6518,7 +6518,7 @@
         <p:spPr>
           <a:xfrm>
             <a:off x="571500" y="1728788"/>
-            <a:ext cx="11049000" cy="3133725"/>
+            <a:ext cx="11049000" cy="2228850"/>
           </a:xfrm>
           <a:prstGeom prst="rect">
             <a:avLst/>
@@ -6527,13 +6527,13 @@
       </p:pic>
       <p:sp>
         <p:nvSpPr>
-          <p:cNvPr id="62" name="Shape 62"/>
-          <p:cNvSpPr/>
-          <p:nvPr/>
-        </p:nvSpPr>
-        <p:spPr>
-          <a:xfrm>
-            <a:off x="571500" y="5091113"/>
+          <p:cNvPr id="411" name="Shape 411"/>
+          <p:cNvSpPr/>
+          <p:nvPr/>
+        </p:nvSpPr>
+        <p:spPr>
+          <a:xfrm>
+            <a:off x="571500" y="4186238"/>
             <a:ext cx="11068050" cy="657225"/>
           </a:xfrm>
           <a:prstGeom prst="rect">
@@ -6561,7 +6561,7 @@
                 <a:latin typeface="Noto Sans SC"/>
                 <a:ea typeface="Noto Sans SC"/>
               </a:rPr>
-              <a:t>命中也有H2D成本；历史重复不保证未来继续访问。</a:t>
+              <a:t>满池仍允许新热点替换旧数据，不以零淘汰为目标。</a:t>
             </a:r>
             <a:r>
               <a:rPr sz="1725" b="0" i="0">
@@ -6582,7 +6582,7 @@
                 <a:latin typeface="Noto Sans SC"/>
                 <a:ea typeface="Noto Sans SC"/>
               </a:rPr>
-              <a:t>预算和时效判断仍是可检验的在线估计。</a:t>
+              <a:t>未知未来、间隔突变和替换价值仍有估计误差。</a:t>
             </a:r>
             <a:endParaRPr lang="en-US"/>
           </a:p>
@@ -6590,7 +6590,7 @@
       </p:sp>
       <p:pic>
         <p:nvPicPr>
-          <p:cNvPr id="124" name="Presenton Native Image 25" descr=""/>
+          <p:cNvPr id="128" name="Presenton Native Image 25" descr=""/>
           <p:cNvPicPr/>
           <p:nvPr/>
         </p:nvPicPr>
@@ -6612,7 +6612,7 @@
       </p:pic>
       <p:sp>
         <p:nvSpPr>
-          <p:cNvPr id="63" name="Shape 63"/>
+          <p:cNvPr id="412" name="Shape 412"/>
           <p:cNvSpPr/>
           <p:nvPr/>
         </p:nvSpPr>
@@ -6654,7 +6654,7 @@
       </p:sp>
       <p:sp>
         <p:nvSpPr>
-          <p:cNvPr id="64" name="Shape 64"/>
+          <p:cNvPr id="413" name="Shape 413"/>
           <p:cNvSpPr/>
           <p:nvPr/>
         </p:nvSpPr>
@@ -6728,7 +6728,7 @@
       </p:grpSpPr>
       <p:pic>
         <p:nvPicPr>
-          <p:cNvPr id="125" name="Presenton Native Image 26" descr=""/>
+          <p:cNvPr id="129" name="Presenton Native Image 26" descr=""/>
           <p:cNvPicPr/>
           <p:nvPr/>
         </p:nvPicPr>
@@ -6750,7 +6750,7 @@
       </p:pic>
       <p:sp>
         <p:nvSpPr>
-          <p:cNvPr id="65" name="Shape 65"/>
+          <p:cNvPr id="414" name="Shape 414"/>
           <p:cNvSpPr/>
           <p:nvPr/>
         </p:nvSpPr>
@@ -6792,7 +6792,7 @@
       </p:sp>
       <p:sp>
         <p:nvSpPr>
-          <p:cNvPr id="66" name="Shape 66"/>
+          <p:cNvPr id="415" name="Shape 415"/>
           <p:cNvSpPr/>
           <p:nvPr/>
         </p:nvSpPr>
@@ -6834,7 +6834,7 @@
       </p:sp>
       <p:sp>
         <p:nvSpPr>
-          <p:cNvPr id="67" name="Shape 67"/>
+          <p:cNvPr id="416" name="Shape 416"/>
           <p:cNvSpPr/>
           <p:nvPr/>
         </p:nvSpPr>
@@ -6868,7 +6868,7 @@
                 <a:latin typeface="Sora"/>
                 <a:ea typeface="Sora"/>
               </a:rPr>
-              <a:t>438条输入，1314次运行及官方回放</a:t>
+              <a:t>481条输入，1443次运行及官方回放</a:t>
             </a:r>
             <a:endParaRPr lang="en-US"/>
           </a:p>
@@ -6876,7 +6876,7 @@
       </p:sp>
       <p:pic>
         <p:nvPicPr>
-          <p:cNvPr id="126" name="Presenton Native Image 27" descr=""/>
+          <p:cNvPr id="130" name="Presenton Native Image 27" descr=""/>
           <p:cNvPicPr/>
           <p:nvPr/>
         </p:nvPicPr>
@@ -6889,7 +6889,7 @@
         <p:spPr>
           <a:xfrm>
             <a:off x="571500" y="1728788"/>
-            <a:ext cx="11049000" cy="3133725"/>
+            <a:ext cx="11049000" cy="2676525"/>
           </a:xfrm>
           <a:prstGeom prst="rect">
             <a:avLst/>
@@ -6898,13 +6898,13 @@
       </p:pic>
       <p:sp>
         <p:nvSpPr>
-          <p:cNvPr id="68" name="Shape 68"/>
-          <p:cNvSpPr/>
-          <p:nvPr/>
-        </p:nvSpPr>
-        <p:spPr>
-          <a:xfrm>
-            <a:off x="571500" y="5129213"/>
+          <p:cNvPr id="417" name="Shape 417"/>
+          <p:cNvSpPr/>
+          <p:nvPr/>
+        </p:nvSpPr>
+        <p:spPr>
+          <a:xfrm>
+            <a:off x="571500" y="4672013"/>
             <a:ext cx="11068050" cy="1066800"/>
           </a:xfrm>
           <a:prstGeom prst="rect">
@@ -6963,7 +6963,7 @@
       </p:sp>
       <p:pic>
         <p:nvPicPr>
-          <p:cNvPr id="127" name="Presenton Native Image 28" descr=""/>
+          <p:cNvPr id="131" name="Presenton Native Image 28" descr=""/>
           <p:cNvPicPr/>
           <p:nvPr/>
         </p:nvPicPr>
@@ -6985,7 +6985,7 @@
       </p:pic>
       <p:sp>
         <p:nvSpPr>
-          <p:cNvPr id="69" name="Shape 69"/>
+          <p:cNvPr id="418" name="Shape 418"/>
           <p:cNvSpPr/>
           <p:nvPr/>
         </p:nvSpPr>
@@ -7027,7 +7027,7 @@
       </p:sp>
       <p:sp>
         <p:nvSpPr>
-          <p:cNvPr id="70" name="Shape 70"/>
+          <p:cNvPr id="419" name="Shape 419"/>
           <p:cNvSpPr/>
           <p:nvPr/>
         </p:nvSpPr>
@@ -7101,7 +7101,7 @@
       </p:grpSpPr>
       <p:pic>
         <p:nvPicPr>
-          <p:cNvPr id="128" name="Presenton Native Image 29" descr=""/>
+          <p:cNvPr id="132" name="Presenton Native Image 29" descr=""/>
           <p:cNvPicPr/>
           <p:nvPr/>
         </p:nvPicPr>
@@ -7123,7 +7123,7 @@
       </p:pic>
       <p:sp>
         <p:nvSpPr>
-          <p:cNvPr id="71" name="Shape 71"/>
+          <p:cNvPr id="420" name="Shape 420"/>
           <p:cNvSpPr/>
           <p:nvPr/>
         </p:nvSpPr>
@@ -7165,7 +7165,7 @@
       </p:sp>
       <p:sp>
         <p:nvSpPr>
-          <p:cNvPr id="72" name="Shape 72"/>
+          <p:cNvPr id="421" name="Shape 421"/>
           <p:cNvSpPr/>
           <p:nvPr/>
         </p:nvSpPr>
@@ -7207,7 +7207,7 @@
       </p:sp>
       <p:sp>
         <p:nvSpPr>
-          <p:cNvPr id="73" name="Shape 73"/>
+          <p:cNvPr id="422" name="Shape 422"/>
           <p:cNvSpPr/>
           <p:nvPr/>
         </p:nvSpPr>
@@ -7249,7 +7249,7 @@
       </p:sp>
       <p:pic>
         <p:nvPicPr>
-          <p:cNvPr id="129" name="Presenton Native Image 30" descr=""/>
+          <p:cNvPr id="133" name="Presenton Native Image 30" descr=""/>
           <p:cNvPicPr/>
           <p:nvPr/>
         </p:nvPicPr>
@@ -7262,7 +7262,7 @@
         <p:spPr>
           <a:xfrm>
             <a:off x="571500" y="1728788"/>
-            <a:ext cx="11049000" cy="3762375"/>
+            <a:ext cx="11049000" cy="3343275"/>
           </a:xfrm>
           <a:prstGeom prst="rect">
             <a:avLst/>
@@ -7271,13 +7271,13 @@
       </p:pic>
       <p:sp>
         <p:nvSpPr>
-          <p:cNvPr id="74" name="Shape 74"/>
-          <p:cNvSpPr/>
-          <p:nvPr/>
-        </p:nvSpPr>
-        <p:spPr>
-          <a:xfrm>
-            <a:off x="571500" y="5681663"/>
+          <p:cNvPr id="423" name="Shape 423"/>
+          <p:cNvSpPr/>
+          <p:nvPr/>
+        </p:nvSpPr>
+        <p:spPr>
+          <a:xfrm>
+            <a:off x="571500" y="5262563"/>
             <a:ext cx="11068050" cy="628650"/>
           </a:xfrm>
           <a:prstGeom prst="rect">
@@ -7334,7 +7334,7 @@
       </p:sp>
       <p:pic>
         <p:nvPicPr>
-          <p:cNvPr id="130" name="Presenton Native Image 31" descr=""/>
+          <p:cNvPr id="134" name="Presenton Native Image 31" descr=""/>
           <p:cNvPicPr/>
           <p:nvPr/>
         </p:nvPicPr>
@@ -7356,7 +7356,7 @@
       </p:pic>
       <p:sp>
         <p:nvSpPr>
-          <p:cNvPr id="75" name="Shape 75"/>
+          <p:cNvPr id="424" name="Shape 424"/>
           <p:cNvSpPr/>
           <p:nvPr/>
         </p:nvSpPr>
@@ -7398,7 +7398,7 @@
       </p:sp>
       <p:sp>
         <p:nvSpPr>
-          <p:cNvPr id="76" name="Shape 76"/>
+          <p:cNvPr id="425" name="Shape 425"/>
           <p:cNvSpPr/>
           <p:nvPr/>
         </p:nvSpPr>

</xml_diff>